<commit_message>
Add the web deck and make the app work at phone widths
The deck now lives in the app as a fifth surface: fourteen slides as native
markup, animated with Motion, reachable at ?view=deck (before onboarding the
Deck tab is the only tab, so a share link opens straight onto it).

Slide 13's recommendation list sizes each row from its measured title, so the
one long title wraps instead of truncating into the genre column, and the rule
under a row follows that row's own last line.

Below 480 px the wordmark yields its space to the tabs so all four stay
labelled; below 380 px the tabs fall back to icons with the label kept as the
accessible name. The strip centres its active tab instead of clipping a
neighbour mid-word. The graph overlay's colour mode and zoom cluster wrap, so
the controls stay reachable at 320 px.

Co-Authored-By: Claude Opus 5.5 <noreply@anthropic.com>
</commit_message>
<xml_diff>
--- a/deck/NextFrame.pptx
+++ b/deck/NextFrame.pptx
@@ -19306,7 +19306,7 @@
         </p:nvSpPr>
         <p:spPr>
           <a:xfrm>
-            <a:off x="5989320" y="1801368"/>
+            <a:off x="5989320" y="1800605"/>
             <a:ext cx="137160" cy="137160"/>
           </a:xfrm>
           <a:prstGeom prst="rect">
@@ -19351,7 +19351,7 @@
         <p:spPr>
           <a:xfrm>
             <a:off x="6263640" y="1773936"/>
-            <a:ext cx="2834640" cy="182880"/>
+            <a:ext cx="2834640" cy="190500"/>
           </a:xfrm>
           <a:prstGeom prst="rect">
             <a:avLst/>
@@ -19395,16 +19395,16 @@
         </p:nvSpPr>
         <p:spPr>
           <a:xfrm>
-            <a:off x="9116567" y="1783080"/>
-            <a:ext cx="1554480" cy="182880"/>
-          </a:xfrm>
-          <a:prstGeom prst="rect">
-            <a:avLst/>
-          </a:prstGeom>
-          <a:noFill/>
-        </p:spPr>
-        <p:txBody>
-          <a:bodyPr wrap="square" lIns="0" rIns="0" tIns="0" bIns="0" anchor="t">
+            <a:off x="9116567" y="1773936"/>
+            <a:ext cx="1554480" cy="190500"/>
+          </a:xfrm>
+          <a:prstGeom prst="rect">
+            <a:avLst/>
+          </a:prstGeom>
+          <a:noFill/>
+        </p:spPr>
+        <p:txBody>
+          <a:bodyPr wrap="square" lIns="0" rIns="0" tIns="0" bIns="0" anchor="ctr">
             <a:spAutoFit/>
           </a:bodyPr>
           <a:lstStyle/>
@@ -19441,20 +19441,20 @@
         <p:spPr>
           <a:xfrm>
             <a:off x="10707624" y="1773936"/>
-            <a:ext cx="310896" cy="182880"/>
-          </a:xfrm>
-          <a:prstGeom prst="rect">
-            <a:avLst/>
-          </a:prstGeom>
-          <a:noFill/>
-        </p:spPr>
-        <p:txBody>
-          <a:bodyPr wrap="square" lIns="0" rIns="0" tIns="0" bIns="0" anchor="t">
-            <a:spAutoFit/>
-          </a:bodyPr>
-          <a:lstStyle/>
-          <a:p>
-            <a:pPr algn="l">
+            <a:ext cx="310896" cy="190500"/>
+          </a:xfrm>
+          <a:prstGeom prst="rect">
+            <a:avLst/>
+          </a:prstGeom>
+          <a:noFill/>
+        </p:spPr>
+        <p:txBody>
+          <a:bodyPr wrap="square" lIns="0" rIns="0" tIns="0" bIns="0" anchor="ctr">
+            <a:spAutoFit/>
+          </a:bodyPr>
+          <a:lstStyle/>
+          <a:p>
+            <a:pPr algn="r">
               <a:lnSpc>
                 <a:spcPct val="125000"/>
               </a:lnSpc>
@@ -19520,7 +19520,7 @@
         </p:nvSpPr>
         <p:spPr>
           <a:xfrm>
-            <a:off x="5989320" y="2180844"/>
+            <a:off x="5989320" y="2159050"/>
             <a:ext cx="137160" cy="137160"/>
           </a:xfrm>
           <a:prstGeom prst="rect">
@@ -19564,8 +19564,8 @@
         </p:nvSpPr>
         <p:spPr>
           <a:xfrm>
-            <a:off x="6263640" y="2153412"/>
-            <a:ext cx="2834640" cy="182880"/>
+            <a:off x="6263640" y="2132380"/>
+            <a:ext cx="2834640" cy="190500"/>
           </a:xfrm>
           <a:prstGeom prst="rect">
             <a:avLst/>
@@ -19609,16 +19609,16 @@
         </p:nvSpPr>
         <p:spPr>
           <a:xfrm>
-            <a:off x="9116567" y="2162556"/>
-            <a:ext cx="1554480" cy="182880"/>
-          </a:xfrm>
-          <a:prstGeom prst="rect">
-            <a:avLst/>
-          </a:prstGeom>
-          <a:noFill/>
-        </p:spPr>
-        <p:txBody>
-          <a:bodyPr wrap="square" lIns="0" rIns="0" tIns="0" bIns="0" anchor="t">
+            <a:off x="9116567" y="2132380"/>
+            <a:ext cx="1554480" cy="190500"/>
+          </a:xfrm>
+          <a:prstGeom prst="rect">
+            <a:avLst/>
+          </a:prstGeom>
+          <a:noFill/>
+        </p:spPr>
+        <p:txBody>
+          <a:bodyPr wrap="square" lIns="0" rIns="0" tIns="0" bIns="0" anchor="ctr">
             <a:spAutoFit/>
           </a:bodyPr>
           <a:lstStyle/>
@@ -19654,21 +19654,21 @@
         </p:nvSpPr>
         <p:spPr>
           <a:xfrm>
-            <a:off x="10707624" y="2153412"/>
-            <a:ext cx="310896" cy="182880"/>
-          </a:xfrm>
-          <a:prstGeom prst="rect">
-            <a:avLst/>
-          </a:prstGeom>
-          <a:noFill/>
-        </p:spPr>
-        <p:txBody>
-          <a:bodyPr wrap="square" lIns="0" rIns="0" tIns="0" bIns="0" anchor="t">
-            <a:spAutoFit/>
-          </a:bodyPr>
-          <a:lstStyle/>
-          <a:p>
-            <a:pPr algn="l">
+            <a:off x="10707624" y="2132380"/>
+            <a:ext cx="310896" cy="190500"/>
+          </a:xfrm>
+          <a:prstGeom prst="rect">
+            <a:avLst/>
+          </a:prstGeom>
+          <a:noFill/>
+        </p:spPr>
+        <p:txBody>
+          <a:bodyPr wrap="square" lIns="0" rIns="0" tIns="0" bIns="0" anchor="ctr">
+            <a:spAutoFit/>
+          </a:bodyPr>
+          <a:lstStyle/>
+          <a:p>
+            <a:pPr algn="r">
               <a:lnSpc>
                 <a:spcPct val="125000"/>
               </a:lnSpc>
@@ -19699,7 +19699,7 @@
         </p:nvCxnSpPr>
         <p:spPr>
           <a:xfrm>
-            <a:off x="5989320" y="2446020"/>
+            <a:off x="5989320" y="2424988"/>
             <a:ext cx="5029200" cy="0"/>
           </a:xfrm>
           <a:prstGeom prst="line">
@@ -19734,7 +19734,7 @@
         </p:nvSpPr>
         <p:spPr>
           <a:xfrm>
-            <a:off x="5989320" y="2560320"/>
+            <a:off x="5989320" y="2517495"/>
             <a:ext cx="137160" cy="137160"/>
           </a:xfrm>
           <a:prstGeom prst="rect">
@@ -19778,8 +19778,8 @@
         </p:nvSpPr>
         <p:spPr>
           <a:xfrm>
-            <a:off x="6263640" y="2532888"/>
-            <a:ext cx="2834640" cy="182880"/>
+            <a:off x="6263640" y="2490825"/>
+            <a:ext cx="2834640" cy="190500"/>
           </a:xfrm>
           <a:prstGeom prst="rect">
             <a:avLst/>
@@ -19823,16 +19823,16 @@
         </p:nvSpPr>
         <p:spPr>
           <a:xfrm>
-            <a:off x="9116567" y="2542032"/>
-            <a:ext cx="1554480" cy="182880"/>
-          </a:xfrm>
-          <a:prstGeom prst="rect">
-            <a:avLst/>
-          </a:prstGeom>
-          <a:noFill/>
-        </p:spPr>
-        <p:txBody>
-          <a:bodyPr wrap="square" lIns="0" rIns="0" tIns="0" bIns="0" anchor="t">
+            <a:off x="9116567" y="2490825"/>
+            <a:ext cx="1554480" cy="190500"/>
+          </a:xfrm>
+          <a:prstGeom prst="rect">
+            <a:avLst/>
+          </a:prstGeom>
+          <a:noFill/>
+        </p:spPr>
+        <p:txBody>
+          <a:bodyPr wrap="square" lIns="0" rIns="0" tIns="0" bIns="0" anchor="ctr">
             <a:spAutoFit/>
           </a:bodyPr>
           <a:lstStyle/>
@@ -19868,21 +19868,21 @@
         </p:nvSpPr>
         <p:spPr>
           <a:xfrm>
-            <a:off x="10707624" y="2532888"/>
-            <a:ext cx="310896" cy="182880"/>
-          </a:xfrm>
-          <a:prstGeom prst="rect">
-            <a:avLst/>
-          </a:prstGeom>
-          <a:noFill/>
-        </p:spPr>
-        <p:txBody>
-          <a:bodyPr wrap="square" lIns="0" rIns="0" tIns="0" bIns="0" anchor="t">
-            <a:spAutoFit/>
-          </a:bodyPr>
-          <a:lstStyle/>
-          <a:p>
-            <a:pPr algn="l">
+            <a:off x="10707624" y="2490825"/>
+            <a:ext cx="310896" cy="190500"/>
+          </a:xfrm>
+          <a:prstGeom prst="rect">
+            <a:avLst/>
+          </a:prstGeom>
+          <a:noFill/>
+        </p:spPr>
+        <p:txBody>
+          <a:bodyPr wrap="square" lIns="0" rIns="0" tIns="0" bIns="0" anchor="ctr">
+            <a:spAutoFit/>
+          </a:bodyPr>
+          <a:lstStyle/>
+          <a:p>
+            <a:pPr algn="r">
               <a:lnSpc>
                 <a:spcPct val="125000"/>
               </a:lnSpc>
@@ -19913,7 +19913,7 @@
         </p:nvCxnSpPr>
         <p:spPr>
           <a:xfrm>
-            <a:off x="5989320" y="2825496"/>
+            <a:off x="5989320" y="2783433"/>
             <a:ext cx="5029200" cy="0"/>
           </a:xfrm>
           <a:prstGeom prst="line">
@@ -19948,7 +19948,7 @@
         </p:nvSpPr>
         <p:spPr>
           <a:xfrm>
-            <a:off x="5989320" y="2939795"/>
+            <a:off x="5989320" y="2875940"/>
             <a:ext cx="137160" cy="137160"/>
           </a:xfrm>
           <a:prstGeom prst="rect">
@@ -19992,8 +19992,8 @@
         </p:nvSpPr>
         <p:spPr>
           <a:xfrm>
-            <a:off x="6263640" y="2912363"/>
-            <a:ext cx="2834640" cy="182880"/>
+            <a:off x="6263640" y="2849270"/>
+            <a:ext cx="2834640" cy="190500"/>
           </a:xfrm>
           <a:prstGeom prst="rect">
             <a:avLst/>
@@ -20037,16 +20037,16 @@
         </p:nvSpPr>
         <p:spPr>
           <a:xfrm>
-            <a:off x="9116567" y="2921507"/>
-            <a:ext cx="1554480" cy="182880"/>
-          </a:xfrm>
-          <a:prstGeom prst="rect">
-            <a:avLst/>
-          </a:prstGeom>
-          <a:noFill/>
-        </p:spPr>
-        <p:txBody>
-          <a:bodyPr wrap="square" lIns="0" rIns="0" tIns="0" bIns="0" anchor="t">
+            <a:off x="9116567" y="2849270"/>
+            <a:ext cx="1554480" cy="190500"/>
+          </a:xfrm>
+          <a:prstGeom prst="rect">
+            <a:avLst/>
+          </a:prstGeom>
+          <a:noFill/>
+        </p:spPr>
+        <p:txBody>
+          <a:bodyPr wrap="square" lIns="0" rIns="0" tIns="0" bIns="0" anchor="ctr">
             <a:spAutoFit/>
           </a:bodyPr>
           <a:lstStyle/>
@@ -20082,21 +20082,21 @@
         </p:nvSpPr>
         <p:spPr>
           <a:xfrm>
-            <a:off x="10707624" y="2912363"/>
-            <a:ext cx="310896" cy="182880"/>
-          </a:xfrm>
-          <a:prstGeom prst="rect">
-            <a:avLst/>
-          </a:prstGeom>
-          <a:noFill/>
-        </p:spPr>
-        <p:txBody>
-          <a:bodyPr wrap="square" lIns="0" rIns="0" tIns="0" bIns="0" anchor="t">
-            <a:spAutoFit/>
-          </a:bodyPr>
-          <a:lstStyle/>
-          <a:p>
-            <a:pPr algn="l">
+            <a:off x="10707624" y="2849270"/>
+            <a:ext cx="310896" cy="190500"/>
+          </a:xfrm>
+          <a:prstGeom prst="rect">
+            <a:avLst/>
+          </a:prstGeom>
+          <a:noFill/>
+        </p:spPr>
+        <p:txBody>
+          <a:bodyPr wrap="square" lIns="0" rIns="0" tIns="0" bIns="0" anchor="ctr">
+            <a:spAutoFit/>
+          </a:bodyPr>
+          <a:lstStyle/>
+          <a:p>
+            <a:pPr algn="r">
               <a:lnSpc>
                 <a:spcPct val="125000"/>
               </a:lnSpc>
@@ -20127,7 +20127,7 @@
         </p:nvCxnSpPr>
         <p:spPr>
           <a:xfrm>
-            <a:off x="5989320" y="3204971"/>
+            <a:off x="5989320" y="3141878"/>
             <a:ext cx="5029200" cy="0"/>
           </a:xfrm>
           <a:prstGeom prst="line">
@@ -20162,7 +20162,7 @@
         </p:nvSpPr>
         <p:spPr>
           <a:xfrm>
-            <a:off x="5989320" y="3319271"/>
+            <a:off x="5989320" y="3234385"/>
             <a:ext cx="137160" cy="137160"/>
           </a:xfrm>
           <a:prstGeom prst="rect">
@@ -20206,8 +20206,8 @@
         </p:nvSpPr>
         <p:spPr>
           <a:xfrm>
-            <a:off x="6263640" y="3291839"/>
-            <a:ext cx="2834640" cy="182880"/>
+            <a:off x="6263640" y="3207715"/>
+            <a:ext cx="2834640" cy="381000"/>
           </a:xfrm>
           <a:prstGeom prst="rect">
             <a:avLst/>
@@ -20251,16 +20251,16 @@
         </p:nvSpPr>
         <p:spPr>
           <a:xfrm>
-            <a:off x="9116567" y="3300983"/>
-            <a:ext cx="1554480" cy="182880"/>
-          </a:xfrm>
-          <a:prstGeom prst="rect">
-            <a:avLst/>
-          </a:prstGeom>
-          <a:noFill/>
-        </p:spPr>
-        <p:txBody>
-          <a:bodyPr wrap="square" lIns="0" rIns="0" tIns="0" bIns="0" anchor="t">
+            <a:off x="9116567" y="3207715"/>
+            <a:ext cx="1554480" cy="190500"/>
+          </a:xfrm>
+          <a:prstGeom prst="rect">
+            <a:avLst/>
+          </a:prstGeom>
+          <a:noFill/>
+        </p:spPr>
+        <p:txBody>
+          <a:bodyPr wrap="square" lIns="0" rIns="0" tIns="0" bIns="0" anchor="ctr">
             <a:spAutoFit/>
           </a:bodyPr>
           <a:lstStyle/>
@@ -20296,21 +20296,21 @@
         </p:nvSpPr>
         <p:spPr>
           <a:xfrm>
-            <a:off x="10707624" y="3291839"/>
-            <a:ext cx="310896" cy="182880"/>
-          </a:xfrm>
-          <a:prstGeom prst="rect">
-            <a:avLst/>
-          </a:prstGeom>
-          <a:noFill/>
-        </p:spPr>
-        <p:txBody>
-          <a:bodyPr wrap="square" lIns="0" rIns="0" tIns="0" bIns="0" anchor="t">
-            <a:spAutoFit/>
-          </a:bodyPr>
-          <a:lstStyle/>
-          <a:p>
-            <a:pPr algn="l">
+            <a:off x="10707624" y="3207715"/>
+            <a:ext cx="310896" cy="190500"/>
+          </a:xfrm>
+          <a:prstGeom prst="rect">
+            <a:avLst/>
+          </a:prstGeom>
+          <a:noFill/>
+        </p:spPr>
+        <p:txBody>
+          <a:bodyPr wrap="square" lIns="0" rIns="0" tIns="0" bIns="0" anchor="ctr">
+            <a:spAutoFit/>
+          </a:bodyPr>
+          <a:lstStyle/>
+          <a:p>
+            <a:pPr algn="r">
               <a:lnSpc>
                 <a:spcPct val="125000"/>
               </a:lnSpc>
@@ -20341,7 +20341,7 @@
         </p:nvCxnSpPr>
         <p:spPr>
           <a:xfrm>
-            <a:off x="5989320" y="3584447"/>
+            <a:off x="5989320" y="3690823"/>
             <a:ext cx="5029200" cy="0"/>
           </a:xfrm>
           <a:prstGeom prst="line">
@@ -20376,7 +20376,7 @@
         </p:nvSpPr>
         <p:spPr>
           <a:xfrm>
-            <a:off x="5989320" y="3698748"/>
+            <a:off x="5989320" y="3783329"/>
             <a:ext cx="137160" cy="137160"/>
           </a:xfrm>
           <a:prstGeom prst="rect">
@@ -20420,8 +20420,8 @@
         </p:nvSpPr>
         <p:spPr>
           <a:xfrm>
-            <a:off x="6263640" y="3671315"/>
-            <a:ext cx="2834640" cy="182880"/>
+            <a:off x="6263640" y="3756659"/>
+            <a:ext cx="2834640" cy="190500"/>
           </a:xfrm>
           <a:prstGeom prst="rect">
             <a:avLst/>
@@ -20465,16 +20465,16 @@
         </p:nvSpPr>
         <p:spPr>
           <a:xfrm>
-            <a:off x="9116567" y="3680459"/>
-            <a:ext cx="1554480" cy="182880"/>
-          </a:xfrm>
-          <a:prstGeom prst="rect">
-            <a:avLst/>
-          </a:prstGeom>
-          <a:noFill/>
-        </p:spPr>
-        <p:txBody>
-          <a:bodyPr wrap="square" lIns="0" rIns="0" tIns="0" bIns="0" anchor="t">
+            <a:off x="9116567" y="3756659"/>
+            <a:ext cx="1554480" cy="190500"/>
+          </a:xfrm>
+          <a:prstGeom prst="rect">
+            <a:avLst/>
+          </a:prstGeom>
+          <a:noFill/>
+        </p:spPr>
+        <p:txBody>
+          <a:bodyPr wrap="square" lIns="0" rIns="0" tIns="0" bIns="0" anchor="ctr">
             <a:spAutoFit/>
           </a:bodyPr>
           <a:lstStyle/>
@@ -20510,21 +20510,21 @@
         </p:nvSpPr>
         <p:spPr>
           <a:xfrm>
-            <a:off x="10707624" y="3671315"/>
-            <a:ext cx="310896" cy="182880"/>
-          </a:xfrm>
-          <a:prstGeom prst="rect">
-            <a:avLst/>
-          </a:prstGeom>
-          <a:noFill/>
-        </p:spPr>
-        <p:txBody>
-          <a:bodyPr wrap="square" lIns="0" rIns="0" tIns="0" bIns="0" anchor="t">
-            <a:spAutoFit/>
-          </a:bodyPr>
-          <a:lstStyle/>
-          <a:p>
-            <a:pPr algn="l">
+            <a:off x="10707624" y="3756659"/>
+            <a:ext cx="310896" cy="190500"/>
+          </a:xfrm>
+          <a:prstGeom prst="rect">
+            <a:avLst/>
+          </a:prstGeom>
+          <a:noFill/>
+        </p:spPr>
+        <p:txBody>
+          <a:bodyPr wrap="square" lIns="0" rIns="0" tIns="0" bIns="0" anchor="ctr">
+            <a:spAutoFit/>
+          </a:bodyPr>
+          <a:lstStyle/>
+          <a:p>
+            <a:pPr algn="r">
               <a:lnSpc>
                 <a:spcPct val="125000"/>
               </a:lnSpc>
@@ -20555,7 +20555,7 @@
         </p:nvCxnSpPr>
         <p:spPr>
           <a:xfrm>
-            <a:off x="5989320" y="3963924"/>
+            <a:off x="5989320" y="4049267"/>
             <a:ext cx="5029200" cy="0"/>
           </a:xfrm>
           <a:prstGeom prst="line">
@@ -20590,7 +20590,7 @@
         </p:nvSpPr>
         <p:spPr>
           <a:xfrm>
-            <a:off x="5989320" y="4078224"/>
+            <a:off x="5989320" y="4141774"/>
             <a:ext cx="137160" cy="137160"/>
           </a:xfrm>
           <a:prstGeom prst="rect">
@@ -20634,8 +20634,8 @@
         </p:nvSpPr>
         <p:spPr>
           <a:xfrm>
-            <a:off x="6263640" y="4050791"/>
-            <a:ext cx="2834640" cy="182880"/>
+            <a:off x="6263640" y="4115104"/>
+            <a:ext cx="2834640" cy="190500"/>
           </a:xfrm>
           <a:prstGeom prst="rect">
             <a:avLst/>
@@ -20679,16 +20679,16 @@
         </p:nvSpPr>
         <p:spPr>
           <a:xfrm>
-            <a:off x="9116567" y="4059935"/>
-            <a:ext cx="1554480" cy="182880"/>
-          </a:xfrm>
-          <a:prstGeom prst="rect">
-            <a:avLst/>
-          </a:prstGeom>
-          <a:noFill/>
-        </p:spPr>
-        <p:txBody>
-          <a:bodyPr wrap="square" lIns="0" rIns="0" tIns="0" bIns="0" anchor="t">
+            <a:off x="9116567" y="4115104"/>
+            <a:ext cx="1554480" cy="190500"/>
+          </a:xfrm>
+          <a:prstGeom prst="rect">
+            <a:avLst/>
+          </a:prstGeom>
+          <a:noFill/>
+        </p:spPr>
+        <p:txBody>
+          <a:bodyPr wrap="square" lIns="0" rIns="0" tIns="0" bIns="0" anchor="ctr">
             <a:spAutoFit/>
           </a:bodyPr>
           <a:lstStyle/>
@@ -20724,21 +20724,21 @@
         </p:nvSpPr>
         <p:spPr>
           <a:xfrm>
-            <a:off x="10707624" y="4050791"/>
-            <a:ext cx="310896" cy="182880"/>
-          </a:xfrm>
-          <a:prstGeom prst="rect">
-            <a:avLst/>
-          </a:prstGeom>
-          <a:noFill/>
-        </p:spPr>
-        <p:txBody>
-          <a:bodyPr wrap="square" lIns="0" rIns="0" tIns="0" bIns="0" anchor="t">
-            <a:spAutoFit/>
-          </a:bodyPr>
-          <a:lstStyle/>
-          <a:p>
-            <a:pPr algn="l">
+            <a:off x="10707624" y="4115104"/>
+            <a:ext cx="310896" cy="190500"/>
+          </a:xfrm>
+          <a:prstGeom prst="rect">
+            <a:avLst/>
+          </a:prstGeom>
+          <a:noFill/>
+        </p:spPr>
+        <p:txBody>
+          <a:bodyPr wrap="square" lIns="0" rIns="0" tIns="0" bIns="0" anchor="ctr">
+            <a:spAutoFit/>
+          </a:bodyPr>
+          <a:lstStyle/>
+          <a:p>
+            <a:pPr algn="r">
               <a:lnSpc>
                 <a:spcPct val="125000"/>
               </a:lnSpc>
@@ -20769,7 +20769,7 @@
         </p:nvCxnSpPr>
         <p:spPr>
           <a:xfrm>
-            <a:off x="5989320" y="4343400"/>
+            <a:off x="5989320" y="4407712"/>
             <a:ext cx="5029200" cy="0"/>
           </a:xfrm>
           <a:prstGeom prst="line">
@@ -20804,7 +20804,7 @@
         </p:nvSpPr>
         <p:spPr>
           <a:xfrm>
-            <a:off x="5989320" y="4457700"/>
+            <a:off x="5989320" y="4500219"/>
             <a:ext cx="137160" cy="137160"/>
           </a:xfrm>
           <a:prstGeom prst="rect">
@@ -20848,8 +20848,8 @@
         </p:nvSpPr>
         <p:spPr>
           <a:xfrm>
-            <a:off x="6263640" y="4430268"/>
-            <a:ext cx="2834640" cy="182880"/>
+            <a:off x="6263640" y="4473549"/>
+            <a:ext cx="2834640" cy="190500"/>
           </a:xfrm>
           <a:prstGeom prst="rect">
             <a:avLst/>
@@ -20893,16 +20893,16 @@
         </p:nvSpPr>
         <p:spPr>
           <a:xfrm>
-            <a:off x="9116567" y="4439412"/>
-            <a:ext cx="1554480" cy="182880"/>
-          </a:xfrm>
-          <a:prstGeom prst="rect">
-            <a:avLst/>
-          </a:prstGeom>
-          <a:noFill/>
-        </p:spPr>
-        <p:txBody>
-          <a:bodyPr wrap="square" lIns="0" rIns="0" tIns="0" bIns="0" anchor="t">
+            <a:off x="9116567" y="4473549"/>
+            <a:ext cx="1554480" cy="190500"/>
+          </a:xfrm>
+          <a:prstGeom prst="rect">
+            <a:avLst/>
+          </a:prstGeom>
+          <a:noFill/>
+        </p:spPr>
+        <p:txBody>
+          <a:bodyPr wrap="square" lIns="0" rIns="0" tIns="0" bIns="0" anchor="ctr">
             <a:spAutoFit/>
           </a:bodyPr>
           <a:lstStyle/>
@@ -20938,21 +20938,21 @@
         </p:nvSpPr>
         <p:spPr>
           <a:xfrm>
-            <a:off x="10707624" y="4430268"/>
-            <a:ext cx="310896" cy="182880"/>
-          </a:xfrm>
-          <a:prstGeom prst="rect">
-            <a:avLst/>
-          </a:prstGeom>
-          <a:noFill/>
-        </p:spPr>
-        <p:txBody>
-          <a:bodyPr wrap="square" lIns="0" rIns="0" tIns="0" bIns="0" anchor="t">
-            <a:spAutoFit/>
-          </a:bodyPr>
-          <a:lstStyle/>
-          <a:p>
-            <a:pPr algn="l">
+            <a:off x="10707624" y="4473549"/>
+            <a:ext cx="310896" cy="190500"/>
+          </a:xfrm>
+          <a:prstGeom prst="rect">
+            <a:avLst/>
+          </a:prstGeom>
+          <a:noFill/>
+        </p:spPr>
+        <p:txBody>
+          <a:bodyPr wrap="square" lIns="0" rIns="0" tIns="0" bIns="0" anchor="ctr">
+            <a:spAutoFit/>
+          </a:bodyPr>
+          <a:lstStyle/>
+          <a:p>
+            <a:pPr algn="r">
               <a:lnSpc>
                 <a:spcPct val="125000"/>
               </a:lnSpc>
@@ -20983,7 +20983,7 @@
         </p:nvCxnSpPr>
         <p:spPr>
           <a:xfrm>
-            <a:off x="5989320" y="4722876"/>
+            <a:off x="5989320" y="4766157"/>
             <a:ext cx="5029200" cy="0"/>
           </a:xfrm>
           <a:prstGeom prst="line">
@@ -21018,7 +21018,7 @@
         </p:nvSpPr>
         <p:spPr>
           <a:xfrm>
-            <a:off x="5989320" y="4837176"/>
+            <a:off x="5989320" y="4858664"/>
             <a:ext cx="137160" cy="137160"/>
           </a:xfrm>
           <a:prstGeom prst="rect">
@@ -21062,8 +21062,8 @@
         </p:nvSpPr>
         <p:spPr>
           <a:xfrm>
-            <a:off x="6263640" y="4809744"/>
-            <a:ext cx="2834640" cy="182880"/>
+            <a:off x="6263640" y="4831994"/>
+            <a:ext cx="2834640" cy="190500"/>
           </a:xfrm>
           <a:prstGeom prst="rect">
             <a:avLst/>
@@ -21107,16 +21107,16 @@
         </p:nvSpPr>
         <p:spPr>
           <a:xfrm>
-            <a:off x="9116567" y="4818888"/>
-            <a:ext cx="1554480" cy="182880"/>
-          </a:xfrm>
-          <a:prstGeom prst="rect">
-            <a:avLst/>
-          </a:prstGeom>
-          <a:noFill/>
-        </p:spPr>
-        <p:txBody>
-          <a:bodyPr wrap="square" lIns="0" rIns="0" tIns="0" bIns="0" anchor="t">
+            <a:off x="9116567" y="4831994"/>
+            <a:ext cx="1554480" cy="190500"/>
+          </a:xfrm>
+          <a:prstGeom prst="rect">
+            <a:avLst/>
+          </a:prstGeom>
+          <a:noFill/>
+        </p:spPr>
+        <p:txBody>
+          <a:bodyPr wrap="square" lIns="0" rIns="0" tIns="0" bIns="0" anchor="ctr">
             <a:spAutoFit/>
           </a:bodyPr>
           <a:lstStyle/>
@@ -21152,21 +21152,21 @@
         </p:nvSpPr>
         <p:spPr>
           <a:xfrm>
-            <a:off x="10707624" y="4809744"/>
-            <a:ext cx="310896" cy="182880"/>
-          </a:xfrm>
-          <a:prstGeom prst="rect">
-            <a:avLst/>
-          </a:prstGeom>
-          <a:noFill/>
-        </p:spPr>
-        <p:txBody>
-          <a:bodyPr wrap="square" lIns="0" rIns="0" tIns="0" bIns="0" anchor="t">
-            <a:spAutoFit/>
-          </a:bodyPr>
-          <a:lstStyle/>
-          <a:p>
-            <a:pPr algn="l">
+            <a:off x="10707624" y="4831994"/>
+            <a:ext cx="310896" cy="190500"/>
+          </a:xfrm>
+          <a:prstGeom prst="rect">
+            <a:avLst/>
+          </a:prstGeom>
+          <a:noFill/>
+        </p:spPr>
+        <p:txBody>
+          <a:bodyPr wrap="square" lIns="0" rIns="0" tIns="0" bIns="0" anchor="ctr">
+            <a:spAutoFit/>
+          </a:bodyPr>
+          <a:lstStyle/>
+          <a:p>
+            <a:pPr algn="r">
               <a:lnSpc>
                 <a:spcPct val="125000"/>
               </a:lnSpc>
@@ -21197,7 +21197,7 @@
         </p:nvCxnSpPr>
         <p:spPr>
           <a:xfrm>
-            <a:off x="5989320" y="5102352"/>
+            <a:off x="5989320" y="5124602"/>
             <a:ext cx="5029200" cy="0"/>
           </a:xfrm>
           <a:prstGeom prst="line">
@@ -21232,7 +21232,7 @@
         </p:nvSpPr>
         <p:spPr>
           <a:xfrm>
-            <a:off x="5989320" y="5216652"/>
+            <a:off x="5989320" y="5217109"/>
             <a:ext cx="137160" cy="137160"/>
           </a:xfrm>
           <a:prstGeom prst="rect">
@@ -21276,8 +21276,8 @@
         </p:nvSpPr>
         <p:spPr>
           <a:xfrm>
-            <a:off x="6263640" y="5189220"/>
-            <a:ext cx="2834640" cy="182880"/>
+            <a:off x="6263640" y="5190439"/>
+            <a:ext cx="2834640" cy="190500"/>
           </a:xfrm>
           <a:prstGeom prst="rect">
             <a:avLst/>
@@ -21321,16 +21321,16 @@
         </p:nvSpPr>
         <p:spPr>
           <a:xfrm>
-            <a:off x="9116567" y="5198364"/>
-            <a:ext cx="1554480" cy="182880"/>
-          </a:xfrm>
-          <a:prstGeom prst="rect">
-            <a:avLst/>
-          </a:prstGeom>
-          <a:noFill/>
-        </p:spPr>
-        <p:txBody>
-          <a:bodyPr wrap="square" lIns="0" rIns="0" tIns="0" bIns="0" anchor="t">
+            <a:off x="9116567" y="5190439"/>
+            <a:ext cx="1554480" cy="190500"/>
+          </a:xfrm>
+          <a:prstGeom prst="rect">
+            <a:avLst/>
+          </a:prstGeom>
+          <a:noFill/>
+        </p:spPr>
+        <p:txBody>
+          <a:bodyPr wrap="square" lIns="0" rIns="0" tIns="0" bIns="0" anchor="ctr">
             <a:spAutoFit/>
           </a:bodyPr>
           <a:lstStyle/>
@@ -21366,21 +21366,21 @@
         </p:nvSpPr>
         <p:spPr>
           <a:xfrm>
-            <a:off x="10707624" y="5189220"/>
-            <a:ext cx="310896" cy="182880"/>
-          </a:xfrm>
-          <a:prstGeom prst="rect">
-            <a:avLst/>
-          </a:prstGeom>
-          <a:noFill/>
-        </p:spPr>
-        <p:txBody>
-          <a:bodyPr wrap="square" lIns="0" rIns="0" tIns="0" bIns="0" anchor="t">
-            <a:spAutoFit/>
-          </a:bodyPr>
-          <a:lstStyle/>
-          <a:p>
-            <a:pPr algn="l">
+            <a:off x="10707624" y="5190439"/>
+            <a:ext cx="310896" cy="190500"/>
+          </a:xfrm>
+          <a:prstGeom prst="rect">
+            <a:avLst/>
+          </a:prstGeom>
+          <a:noFill/>
+        </p:spPr>
+        <p:txBody>
+          <a:bodyPr wrap="square" lIns="0" rIns="0" tIns="0" bIns="0" anchor="ctr">
+            <a:spAutoFit/>
+          </a:bodyPr>
+          <a:lstStyle/>
+          <a:p>
+            <a:pPr algn="r">
               <a:lnSpc>
                 <a:spcPct val="125000"/>
               </a:lnSpc>
@@ -21411,7 +21411,7 @@
         </p:nvCxnSpPr>
         <p:spPr>
           <a:xfrm>
-            <a:off x="5989320" y="5481828"/>
+            <a:off x="5989320" y="5483047"/>
             <a:ext cx="5029200" cy="0"/>
           </a:xfrm>
           <a:prstGeom prst="line">

</xml_diff>